<commit_message>
feat: add node pipeline diagrams and update presentation slides with revised visual assets and refined technical content
</commit_message>
<xml_diff>
--- a/AquaSense_Pitch_Deck_v2.pptx
+++ b/AquaSense_Pitch_Deck_v2.pptx
@@ -16,7 +16,6 @@
     <p:sldId id="264" r:id="rId15"/>
     <p:sldId id="265" r:id="rId16"/>
     <p:sldId id="266" r:id="rId17"/>
-    <p:sldId id="267" r:id="rId18"/>
   </p:sldIdLst>
   <p:sldSz cx="12191695" cy="6858000" type="screen4x3"/>
   <p:notesSz cx="6858000" cy="9144000"/>
@@ -3577,7 +3576,7 @@
           </a:p>
           <a:p>
             <a:pPr>
-              <a:defRPr sz="1300" b="1">
+              <a:defRPr sz="1200" b="1">
                 <a:solidFill>
                   <a:srgbClr val="F0FDFA"/>
                 </a:solidFill>
@@ -3899,7 +3898,7 @@
           </a:p>
           <a:p>
             <a:pPr>
-              <a:defRPr sz="1300" b="1">
+              <a:defRPr sz="1200" b="1">
                 <a:solidFill>
                   <a:srgbClr val="F0FDFA"/>
                 </a:solidFill>
@@ -4113,7 +4112,7 @@
         <p:spPr>
           <a:xfrm>
             <a:off x="731520" y="475488"/>
-            <a:ext cx="1645920" cy="256032"/>
+            <a:ext cx="2011680" cy="256032"/>
           </a:xfrm>
           <a:prstGeom prst="roundRect">
             <a:avLst/>
@@ -4719,7 +4718,7 @@
           </a:p>
           <a:p>
             <a:pPr>
-              <a:defRPr sz="1300" b="1">
+              <a:defRPr sz="1200" b="1">
                 <a:solidFill>
                   <a:srgbClr val="F0FDFA"/>
                 </a:solidFill>
@@ -4903,7 +4902,7 @@
           </a:p>
           <a:p>
             <a:pPr>
-              <a:defRPr sz="1300" b="1">
+              <a:defRPr sz="1200" b="1">
                 <a:solidFill>
                   <a:srgbClr val="F0FDFA"/>
                 </a:solidFill>
@@ -5842,7 +5841,7 @@
         <p:spPr>
           <a:xfrm>
             <a:off x="731520" y="475488"/>
-            <a:ext cx="1645920" cy="256032"/>
+            <a:ext cx="2011680" cy="256032"/>
           </a:xfrm>
           <a:prstGeom prst="roundRect">
             <a:avLst/>
@@ -5883,7 +5882,7 @@
               </a:defRPr>
             </a:pPr>
             <a:r>
-              <a:t>ORBIT 11 // GLOBAL IMPACT</a:t>
+              <a:t>ORBIT 11 // STRATEGIC IMPACT &amp; ROADMAP</a:t>
             </a:r>
           </a:p>
         </p:txBody>
@@ -5919,7 +5918,7 @@
               </a:defRPr>
             </a:pPr>
             <a:r>
-              <a:t>Target Stakeholders &amp; Market Applications</a:t>
+              <a:t>Global Stakeholder Applications &amp; Strategic Scaling Roadmap</a:t>
             </a:r>
           </a:p>
           <a:p>
@@ -5935,7 +5934,7 @@
               </a:defRPr>
             </a:pPr>
             <a:r>
-              <a:t>Actionable satellite intelligence serving environmental governance, conservation, smart cities, and ESG markets.</a:t>
+              <a:t>Transforming satellite observation into verifiable conservation policy, smart city resilience, and planetary hydro-intelligence.</a:t>
             </a:r>
           </a:p>
         </p:txBody>
@@ -5948,14 +5947,111 @@
         </p:nvSpPr>
         <p:spPr>
           <a:xfrm>
-            <a:off x="731520" y="1645920"/>
-            <a:ext cx="2560320" cy="4480560"/>
+            <a:off x="731520" y="1600200"/>
+            <a:ext cx="5212080" cy="4572000"/>
           </a:xfrm>
           <a:prstGeom prst="rect">
             <a:avLst/>
           </a:prstGeom>
           <a:solidFill>
             <a:srgbClr val="0C1E3D"/>
+          </a:solidFill>
+          <a:ln w="12700">
+            <a:solidFill>
+              <a:srgbClr val="0284C7"/>
+            </a:solidFill>
+          </a:ln>
+        </p:spPr>
+        <p:style>
+          <a:lnRef idx="1">
+            <a:schemeClr val="accent1"/>
+          </a:lnRef>
+          <a:fillRef idx="3">
+            <a:schemeClr val="accent1"/>
+          </a:fillRef>
+          <a:effectRef idx="2">
+            <a:schemeClr val="accent1"/>
+          </a:effectRef>
+          <a:fontRef idx="minor">
+            <a:schemeClr val="lt1"/>
+          </a:fontRef>
+        </p:style>
+        <p:txBody>
+          <a:bodyPr rtlCol="0" anchor="ctr"/>
+          <a:lstStyle/>
+          <a:p>
+            <a:pPr algn="ctr"/>
+          </a:p>
+        </p:txBody>
+      </p:sp>
+      <p:sp>
+        <p:nvSpPr>
+          <p:cNvPr id="6" name="TextBox 5"/>
+          <p:cNvSpPr txBox="1"/>
+          <p:nvPr/>
+        </p:nvSpPr>
+        <p:spPr>
+          <a:xfrm>
+            <a:off x="914400" y="1746504"/>
+            <a:ext cx="4846320" cy="594360"/>
+          </a:xfrm>
+          <a:prstGeom prst="rect">
+            <a:avLst/>
+          </a:prstGeom>
+          <a:noFill/>
+        </p:spPr>
+        <p:txBody>
+          <a:bodyPr wrap="square" lIns="0" tIns="0" rIns="0" bIns="0">
+            <a:spAutoFit/>
+          </a:bodyPr>
+          <a:lstStyle/>
+          <a:p>
+            <a:pPr>
+              <a:spcAft>
+                <a:spcPts val="200"/>
+              </a:spcAft>
+              <a:defRPr sz="800" b="1">
+                <a:solidFill>
+                  <a:srgbClr val="22D3EE"/>
+                </a:solidFill>
+                <a:latin typeface="Consolas"/>
+              </a:defRPr>
+            </a:pPr>
+            <a:r>
+              <a:t>GLOBAL APPLICATION DOMAINS</a:t>
+            </a:r>
+          </a:p>
+          <a:p>
+            <a:pPr>
+              <a:defRPr sz="1200" b="1">
+                <a:solidFill>
+                  <a:srgbClr val="F0FDFA"/>
+                </a:solidFill>
+                <a:latin typeface="Trebuchet MS"/>
+              </a:defRPr>
+            </a:pPr>
+            <a:r>
+              <a:t>Target Stakeholders &amp; Real-World Impact</a:t>
+            </a:r>
+          </a:p>
+        </p:txBody>
+      </p:sp>
+      <p:sp>
+        <p:nvSpPr>
+          <p:cNvPr id="7" name="Rectangle 6"/>
+          <p:cNvSpPr/>
+          <p:nvPr/>
+        </p:nvSpPr>
+        <p:spPr>
+          <a:xfrm>
+            <a:off x="914400" y="2240280"/>
+            <a:ext cx="2331720" cy="1783080"/>
+          </a:xfrm>
+          <a:prstGeom prst="rect">
+            <a:avLst/>
+          </a:prstGeom>
+          <a:solidFill>
+            <a:srgbClr val="071326"/>
           </a:solidFill>
           <a:ln w="12700">
             <a:solidFill>
@@ -5987,14 +6083,14 @@
       </p:sp>
       <p:sp>
         <p:nvSpPr>
-          <p:cNvPr id="6" name="TextBox 5"/>
+          <p:cNvPr id="8" name="TextBox 7"/>
           <p:cNvSpPr txBox="1"/>
           <p:nvPr/>
         </p:nvSpPr>
         <p:spPr>
           <a:xfrm>
-            <a:off x="914400" y="1792224"/>
-            <a:ext cx="2194560" cy="594360"/>
+            <a:off x="1005840" y="2331720"/>
+            <a:ext cx="2148840" cy="1600200"/>
           </a:xfrm>
           <a:prstGeom prst="rect">
             <a:avLst/>
@@ -6008,45 +6104,135 @@
           <a:lstStyle/>
           <a:p>
             <a:pPr>
+              <a:defRPr sz="850" b="1">
+                <a:solidFill>
+                  <a:srgbClr val="22D3EE"/>
+                </a:solidFill>
+                <a:latin typeface="Trebuchet MS"/>
+              </a:defRPr>
+            </a:pPr>
+            <a:r>
+              <a:t>🏛️ GOVERNANCE &amp; POLICY</a:t>
+            </a:r>
+          </a:p>
+          <a:p>
+            <a:pPr>
+              <a:spcAft>
+                <a:spcPts val="300"/>
+              </a:spcAft>
+              <a:defRPr sz="700" b="1">
+                <a:solidFill>
+                  <a:srgbClr val="738CAD"/>
+                </a:solidFill>
+                <a:latin typeface="Consolas"/>
+              </a:defRPr>
+            </a:pPr>
+            <a:r>
+              <a:t>WETLAND AUTHORITIES</a:t>
+            </a:r>
+          </a:p>
+          <a:p>
+            <a:pPr>
               <a:spcAft>
                 <a:spcPts val="200"/>
               </a:spcAft>
-              <a:defRPr sz="800" b="1">
-                <a:solidFill>
-                  <a:srgbClr val="22D3EE"/>
-                </a:solidFill>
-                <a:latin typeface="Consolas"/>
-              </a:defRPr>
-            </a:pPr>
-            <a:r>
-              <a:t>WETLAND AUTHORITIES</a:t>
-            </a:r>
-          </a:p>
-          <a:p>
-            <a:pPr>
-              <a:defRPr sz="1300" b="1">
-                <a:solidFill>
-                  <a:srgbClr val="F0FDFA"/>
-                </a:solidFill>
-                <a:latin typeface="Trebuchet MS"/>
-              </a:defRPr>
-            </a:pPr>
-            <a:r>
-              <a:t>🏛️ GOVERNANCE &amp; POLICY</a:t>
-            </a:r>
-          </a:p>
-        </p:txBody>
-      </p:sp>
-      <p:sp>
-        <p:nvSpPr>
-          <p:cNvPr id="7" name="TextBox 6"/>
+              <a:defRPr sz="800">
+                <a:solidFill>
+                  <a:srgbClr val="CADAEE"/>
+                </a:solidFill>
+              </a:defRPr>
+            </a:pPr>
+            <a:r>
+              <a:t>• Ramsar &amp; Biodiversity compliance reporting.</a:t>
+            </a:r>
+          </a:p>
+          <a:p>
+            <a:pPr>
+              <a:spcAft>
+                <a:spcPts val="200"/>
+              </a:spcAft>
+              <a:defRPr sz="800">
+                <a:solidFill>
+                  <a:srgbClr val="CADAEE"/>
+                </a:solidFill>
+              </a:defRPr>
+            </a:pPr>
+            <a:r>
+              <a:t>• Automated alerts on illegal landfilling.</a:t>
+            </a:r>
+          </a:p>
+          <a:p>
+            <a:pPr>
+              <a:spcAft>
+                <a:spcPts val="200"/>
+              </a:spcAft>
+              <a:defRPr sz="800">
+                <a:solidFill>
+                  <a:srgbClr val="CADAEE"/>
+                </a:solidFill>
+              </a:defRPr>
+            </a:pPr>
+            <a:r>
+              <a:t>• Court-admissible proof (hash: 0x8a92f02c).</a:t>
+            </a:r>
+          </a:p>
+        </p:txBody>
+      </p:sp>
+      <p:sp>
+        <p:nvSpPr>
+          <p:cNvPr id="9" name="Rectangle 8"/>
+          <p:cNvSpPr/>
+          <p:nvPr/>
+        </p:nvSpPr>
+        <p:spPr>
+          <a:xfrm>
+            <a:off x="3383280" y="2240280"/>
+            <a:ext cx="2331720" cy="1783080"/>
+          </a:xfrm>
+          <a:prstGeom prst="rect">
+            <a:avLst/>
+          </a:prstGeom>
+          <a:solidFill>
+            <a:srgbClr val="071326"/>
+          </a:solidFill>
+          <a:ln w="12700">
+            <a:solidFill>
+              <a:srgbClr val="06D6A0"/>
+            </a:solidFill>
+          </a:ln>
+        </p:spPr>
+        <p:style>
+          <a:lnRef idx="1">
+            <a:schemeClr val="accent1"/>
+          </a:lnRef>
+          <a:fillRef idx="3">
+            <a:schemeClr val="accent1"/>
+          </a:fillRef>
+          <a:effectRef idx="2">
+            <a:schemeClr val="accent1"/>
+          </a:effectRef>
+          <a:fontRef idx="minor">
+            <a:schemeClr val="lt1"/>
+          </a:fontRef>
+        </p:style>
+        <p:txBody>
+          <a:bodyPr rtlCol="0" anchor="ctr"/>
+          <a:lstStyle/>
+          <a:p>
+            <a:pPr algn="ctr"/>
+          </a:p>
+        </p:txBody>
+      </p:sp>
+      <p:sp>
+        <p:nvSpPr>
+          <p:cNvPr id="10" name="TextBox 9"/>
           <p:cNvSpPr txBox="1"/>
           <p:nvPr/>
         </p:nvSpPr>
         <p:spPr>
           <a:xfrm>
-            <a:off x="914400" y="2423160"/>
-            <a:ext cx="2194560" cy="3566160"/>
+            <a:off x="3474720" y="2331720"/>
+            <a:ext cx="2148840" cy="1600200"/>
           </a:xfrm>
           <a:prstGeom prst="rect">
             <a:avLst/>
@@ -6060,80 +6246,374 @@
           <a:lstStyle/>
           <a:p>
             <a:pPr>
-              <a:spcAft>
-                <a:spcPts val="600"/>
-              </a:spcAft>
-              <a:defRPr sz="950">
-                <a:solidFill>
-                  <a:srgbClr val="CADAEE"/>
-                </a:solidFill>
-                <a:latin typeface="Calibri"/>
-              </a:defRPr>
-            </a:pPr>
-            <a:r>
-              <a:t>• Ramsar Convention &amp; National Biodiversity reporting.</a:t>
-            </a:r>
-          </a:p>
-          <a:p>
-            <a:pPr>
-              <a:spcAft>
-                <a:spcPts val="600"/>
-              </a:spcAft>
-              <a:defRPr sz="950">
-                <a:solidFill>
-                  <a:srgbClr val="CADAEE"/>
-                </a:solidFill>
-                <a:latin typeface="Calibri"/>
-              </a:defRPr>
-            </a:pPr>
-            <a:r>
-              <a:t>• Automated detection of illegal landfilling &amp; construction.</a:t>
-            </a:r>
-          </a:p>
-          <a:p>
-            <a:pPr>
-              <a:spcAft>
-                <a:spcPts val="600"/>
-              </a:spcAft>
-              <a:defRPr sz="950">
-                <a:solidFill>
-                  <a:srgbClr val="CADAEE"/>
-                </a:solidFill>
-                <a:latin typeface="Calibri"/>
-              </a:defRPr>
-            </a:pPr>
-            <a:r>
-              <a:t>• Court-admissible satellite evidence for legal enforcement.</a:t>
-            </a:r>
-          </a:p>
-          <a:p>
-            <a:pPr>
-              <a:spcAft>
-                <a:spcPts val="600"/>
-              </a:spcAft>
-              <a:defRPr sz="950">
-                <a:solidFill>
-                  <a:srgbClr val="CADAEE"/>
-                </a:solidFill>
-                <a:latin typeface="Calibri"/>
-              </a:defRPr>
-            </a:pPr>
-            <a:r>
-              <a:t>• Transparent verification of municipal conservation budgets.</a:t>
-            </a:r>
-          </a:p>
-        </p:txBody>
-      </p:sp>
-      <p:sp>
-        <p:nvSpPr>
-          <p:cNvPr id="8" name="Rectangle 7"/>
+              <a:defRPr sz="850" b="1">
+                <a:solidFill>
+                  <a:srgbClr val="06D6A0"/>
+                </a:solidFill>
+                <a:latin typeface="Trebuchet MS"/>
+              </a:defRPr>
+            </a:pPr>
+            <a:r>
+              <a:t>🌱 CONSERVATION NGOS</a:t>
+            </a:r>
+          </a:p>
+          <a:p>
+            <a:pPr>
+              <a:spcAft>
+                <a:spcPts val="300"/>
+              </a:spcAft>
+              <a:defRPr sz="700" b="1">
+                <a:solidFill>
+                  <a:srgbClr val="738CAD"/>
+                </a:solidFill>
+                <a:latin typeface="Consolas"/>
+              </a:defRPr>
+            </a:pPr>
+            <a:r>
+              <a:t>ECOLOGISTS &amp; ADVOCACY</a:t>
+            </a:r>
+          </a:p>
+          <a:p>
+            <a:pPr>
+              <a:spcAft>
+                <a:spcPts val="200"/>
+              </a:spcAft>
+              <a:defRPr sz="800">
+                <a:solidFill>
+                  <a:srgbClr val="CADAEE"/>
+                </a:solidFill>
+              </a:defRPr>
+            </a:pPr>
+            <a:r>
+              <a:t>• Continuous remote monitoring of basins.</a:t>
+            </a:r>
+          </a:p>
+          <a:p>
+            <a:pPr>
+              <a:spcAft>
+                <a:spcPts val="200"/>
+              </a:spcAft>
+              <a:defRPr sz="800">
+                <a:solidFill>
+                  <a:srgbClr val="CADAEE"/>
+                </a:solidFill>
+              </a:defRPr>
+            </a:pPr>
+            <a:r>
+              <a:t>• Field photo ground-truthing portal.</a:t>
+            </a:r>
+          </a:p>
+          <a:p>
+            <a:pPr>
+              <a:spcAft>
+                <a:spcPts val="200"/>
+              </a:spcAft>
+              <a:defRPr sz="800">
+                <a:solidFill>
+                  <a:srgbClr val="CADAEE"/>
+                </a:solidFill>
+              </a:defRPr>
+            </a:pPr>
+            <a:r>
+              <a:t>• Multi-year trend data for climate grants.</a:t>
+            </a:r>
+          </a:p>
+        </p:txBody>
+      </p:sp>
+      <p:sp>
+        <p:nvSpPr>
+          <p:cNvPr id="11" name="Rectangle 10"/>
           <p:cNvSpPr/>
           <p:nvPr/>
         </p:nvSpPr>
         <p:spPr>
           <a:xfrm>
-            <a:off x="3474720" y="1645920"/>
-            <a:ext cx="2560320" cy="4480560"/>
+            <a:off x="914400" y="4114800"/>
+            <a:ext cx="2331720" cy="1783080"/>
+          </a:xfrm>
+          <a:prstGeom prst="rect">
+            <a:avLst/>
+          </a:prstGeom>
+          <a:solidFill>
+            <a:srgbClr val="071326"/>
+          </a:solidFill>
+          <a:ln w="12700">
+            <a:solidFill>
+              <a:srgbClr val="FBBF24"/>
+            </a:solidFill>
+          </a:ln>
+        </p:spPr>
+        <p:style>
+          <a:lnRef idx="1">
+            <a:schemeClr val="accent1"/>
+          </a:lnRef>
+          <a:fillRef idx="3">
+            <a:schemeClr val="accent1"/>
+          </a:fillRef>
+          <a:effectRef idx="2">
+            <a:schemeClr val="accent1"/>
+          </a:effectRef>
+          <a:fontRef idx="minor">
+            <a:schemeClr val="lt1"/>
+          </a:fontRef>
+        </p:style>
+        <p:txBody>
+          <a:bodyPr rtlCol="0" anchor="ctr"/>
+          <a:lstStyle/>
+          <a:p>
+            <a:pPr algn="ctr"/>
+          </a:p>
+        </p:txBody>
+      </p:sp>
+      <p:sp>
+        <p:nvSpPr>
+          <p:cNvPr id="12" name="TextBox 11"/>
+          <p:cNvSpPr txBox="1"/>
+          <p:nvPr/>
+        </p:nvSpPr>
+        <p:spPr>
+          <a:xfrm>
+            <a:off x="1005840" y="4206240"/>
+            <a:ext cx="2148840" cy="1600200"/>
+          </a:xfrm>
+          <a:prstGeom prst="rect">
+            <a:avLst/>
+          </a:prstGeom>
+          <a:noFill/>
+        </p:spPr>
+        <p:txBody>
+          <a:bodyPr wrap="square" lIns="0" tIns="0" rIns="0" bIns="0">
+            <a:spAutoFit/>
+          </a:bodyPr>
+          <a:lstStyle/>
+          <a:p>
+            <a:pPr>
+              <a:defRPr sz="850" b="1">
+                <a:solidFill>
+                  <a:srgbClr val="FBBF24"/>
+                </a:solidFill>
+                <a:latin typeface="Trebuchet MS"/>
+              </a:defRPr>
+            </a:pPr>
+            <a:r>
+              <a:t>🏙️ SMART CITIES &amp; PLANNERS</a:t>
+            </a:r>
+          </a:p>
+          <a:p>
+            <a:pPr>
+              <a:spcAft>
+                <a:spcPts val="300"/>
+              </a:spcAft>
+              <a:defRPr sz="700" b="1">
+                <a:solidFill>
+                  <a:srgbClr val="738CAD"/>
+                </a:solidFill>
+                <a:latin typeface="Consolas"/>
+              </a:defRPr>
+            </a:pPr>
+            <a:r>
+              <a:t>FLOOD ATTENUATION</a:t>
+            </a:r>
+          </a:p>
+          <a:p>
+            <a:pPr>
+              <a:spcAft>
+                <a:spcPts val="200"/>
+              </a:spcAft>
+              <a:defRPr sz="800">
+                <a:solidFill>
+                  <a:srgbClr val="CADAEE"/>
+                </a:solidFill>
+              </a:defRPr>
+            </a:pPr>
+            <a:r>
+              <a:t>• Pre-monsoon water holding capacity checks.</a:t>
+            </a:r>
+          </a:p>
+          <a:p>
+            <a:pPr>
+              <a:spcAft>
+                <a:spcPts val="200"/>
+              </a:spcAft>
+              <a:defRPr sz="800">
+                <a:solidFill>
+                  <a:srgbClr val="CADAEE"/>
+                </a:solidFill>
+              </a:defRPr>
+            </a:pPr>
+            <a:r>
+              <a:t>• Critical urban flood buffer preservation.</a:t>
+            </a:r>
+          </a:p>
+          <a:p>
+            <a:pPr>
+              <a:spcAft>
+                <a:spcPts val="200"/>
+              </a:spcAft>
+              <a:defRPr sz="800">
+                <a:solidFill>
+                  <a:srgbClr val="CADAEE"/>
+                </a:solidFill>
+              </a:defRPr>
+            </a:pPr>
+            <a:r>
+              <a:t>• City emergency dashboard integration.</a:t>
+            </a:r>
+          </a:p>
+        </p:txBody>
+      </p:sp>
+      <p:sp>
+        <p:nvSpPr>
+          <p:cNvPr id="13" name="Rectangle 12"/>
+          <p:cNvSpPr/>
+          <p:nvPr/>
+        </p:nvSpPr>
+        <p:spPr>
+          <a:xfrm>
+            <a:off x="3383280" y="4114800"/>
+            <a:ext cx="2331720" cy="1783080"/>
+          </a:xfrm>
+          <a:prstGeom prst="rect">
+            <a:avLst/>
+          </a:prstGeom>
+          <a:solidFill>
+            <a:srgbClr val="071326"/>
+          </a:solidFill>
+          <a:ln w="12700">
+            <a:solidFill>
+              <a:srgbClr val="F43F5E"/>
+            </a:solidFill>
+          </a:ln>
+        </p:spPr>
+        <p:style>
+          <a:lnRef idx="1">
+            <a:schemeClr val="accent1"/>
+          </a:lnRef>
+          <a:fillRef idx="3">
+            <a:schemeClr val="accent1"/>
+          </a:fillRef>
+          <a:effectRef idx="2">
+            <a:schemeClr val="accent1"/>
+          </a:effectRef>
+          <a:fontRef idx="minor">
+            <a:schemeClr val="lt1"/>
+          </a:fontRef>
+        </p:style>
+        <p:txBody>
+          <a:bodyPr rtlCol="0" anchor="ctr"/>
+          <a:lstStyle/>
+          <a:p>
+            <a:pPr algn="ctr"/>
+          </a:p>
+        </p:txBody>
+      </p:sp>
+      <p:sp>
+        <p:nvSpPr>
+          <p:cNvPr id="14" name="TextBox 13"/>
+          <p:cNvSpPr txBox="1"/>
+          <p:nvPr/>
+        </p:nvSpPr>
+        <p:spPr>
+          <a:xfrm>
+            <a:off x="3474720" y="4206240"/>
+            <a:ext cx="2148840" cy="1600200"/>
+          </a:xfrm>
+          <a:prstGeom prst="rect">
+            <a:avLst/>
+          </a:prstGeom>
+          <a:noFill/>
+        </p:spPr>
+        <p:txBody>
+          <a:bodyPr wrap="square" lIns="0" tIns="0" rIns="0" bIns="0">
+            <a:spAutoFit/>
+          </a:bodyPr>
+          <a:lstStyle/>
+          <a:p>
+            <a:pPr>
+              <a:defRPr sz="850" b="1">
+                <a:solidFill>
+                  <a:srgbClr val="F43F5E"/>
+                </a:solidFill>
+                <a:latin typeface="Trebuchet MS"/>
+              </a:defRPr>
+            </a:pPr>
+            <a:r>
+              <a:t>💼 ESG &amp; BLUE CARBON</a:t>
+            </a:r>
+          </a:p>
+          <a:p>
+            <a:pPr>
+              <a:spcAft>
+                <a:spcPts val="300"/>
+              </a:spcAft>
+              <a:defRPr sz="700" b="1">
+                <a:solidFill>
+                  <a:srgbClr val="738CAD"/>
+                </a:solidFill>
+                <a:latin typeface="Consolas"/>
+              </a:defRPr>
+            </a:pPr>
+            <a:r>
+              <a:t>SUSTAINABILITY AUDIT</a:t>
+            </a:r>
+          </a:p>
+          <a:p>
+            <a:pPr>
+              <a:spcAft>
+                <a:spcPts val="200"/>
+              </a:spcAft>
+              <a:defRPr sz="800">
+                <a:solidFill>
+                  <a:srgbClr val="CADAEE"/>
+                </a:solidFill>
+              </a:defRPr>
+            </a:pPr>
+            <a:r>
+              <a:t>• Independent satellite MRV verification.</a:t>
+            </a:r>
+          </a:p>
+          <a:p>
+            <a:pPr>
+              <a:spcAft>
+                <a:spcPts val="200"/>
+              </a:spcAft>
+              <a:defRPr sz="800">
+                <a:solidFill>
+                  <a:srgbClr val="CADAEE"/>
+                </a:solidFill>
+              </a:defRPr>
+            </a:pPr>
+            <a:r>
+              <a:t>• Auditable wetland carbon credit validation.</a:t>
+            </a:r>
+          </a:p>
+          <a:p>
+            <a:pPr>
+              <a:spcAft>
+                <a:spcPts val="200"/>
+              </a:spcAft>
+              <a:defRPr sz="800">
+                <a:solidFill>
+                  <a:srgbClr val="CADAEE"/>
+                </a:solidFill>
+              </a:defRPr>
+            </a:pPr>
+            <a:r>
+              <a:t>• Corporate water stewardship reporting.</a:t>
+            </a:r>
+          </a:p>
+        </p:txBody>
+      </p:sp>
+      <p:sp>
+        <p:nvSpPr>
+          <p:cNvPr id="15" name="Rectangle 14"/>
+          <p:cNvSpPr/>
+          <p:nvPr/>
+        </p:nvSpPr>
+        <p:spPr>
+          <a:xfrm>
+            <a:off x="6217920" y="1600200"/>
+            <a:ext cx="5212080" cy="4572000"/>
           </a:xfrm>
           <a:prstGeom prst="rect">
             <a:avLst/>
@@ -6171,14 +6651,14 @@
       </p:sp>
       <p:sp>
         <p:nvSpPr>
-          <p:cNvPr id="9" name="TextBox 8"/>
+          <p:cNvPr id="16" name="TextBox 15"/>
           <p:cNvSpPr txBox="1"/>
           <p:nvPr/>
         </p:nvSpPr>
         <p:spPr>
           <a:xfrm>
-            <a:off x="3657600" y="1792224"/>
-            <a:ext cx="2194560" cy="594360"/>
+            <a:off x="6400800" y="1746504"/>
+            <a:ext cx="4846320" cy="594360"/>
           </a:xfrm>
           <a:prstGeom prst="rect">
             <a:avLst/>
@@ -6203,12 +6683,12 @@
               </a:defRPr>
             </a:pPr>
             <a:r>
-              <a:t>ECOLOGISTS &amp; ADVOCACY</a:t>
-            </a:r>
-          </a:p>
-          <a:p>
-            <a:pPr>
-              <a:defRPr sz="1300" b="1">
+              <a:t>PLANETARY DEPLOYMENT PHASES</a:t>
+            </a:r>
+          </a:p>
+          <a:p>
+            <a:pPr>
+              <a:defRPr sz="1200" b="1">
                 <a:solidFill>
                   <a:srgbClr val="F0FDFA"/>
                 </a:solidFill>
@@ -6216,21 +6696,66 @@
               </a:defRPr>
             </a:pPr>
             <a:r>
-              <a:t>🌱 CONSERVATION NGOS</a:t>
-            </a:r>
-          </a:p>
-        </p:txBody>
-      </p:sp>
-      <p:sp>
-        <p:nvSpPr>
-          <p:cNvPr id="10" name="TextBox 9"/>
+              <a:t>Strategic Scaling Roadmap &amp; Milestones</a:t>
+            </a:r>
+          </a:p>
+        </p:txBody>
+      </p:sp>
+      <p:sp>
+        <p:nvSpPr>
+          <p:cNvPr id="17" name="Rectangle 16"/>
+          <p:cNvSpPr/>
+          <p:nvPr/>
+        </p:nvSpPr>
+        <p:spPr>
+          <a:xfrm>
+            <a:off x="6400800" y="2240280"/>
+            <a:ext cx="4846320" cy="841248"/>
+          </a:xfrm>
+          <a:prstGeom prst="rect">
+            <a:avLst/>
+          </a:prstGeom>
+          <a:solidFill>
+            <a:srgbClr val="071326"/>
+          </a:solidFill>
+          <a:ln w="12700">
+            <a:solidFill>
+              <a:srgbClr val="06D6A0"/>
+            </a:solidFill>
+          </a:ln>
+        </p:spPr>
+        <p:style>
+          <a:lnRef idx="1">
+            <a:schemeClr val="accent1"/>
+          </a:lnRef>
+          <a:fillRef idx="3">
+            <a:schemeClr val="accent1"/>
+          </a:fillRef>
+          <a:effectRef idx="2">
+            <a:schemeClr val="accent1"/>
+          </a:effectRef>
+          <a:fontRef idx="minor">
+            <a:schemeClr val="lt1"/>
+          </a:fontRef>
+        </p:style>
+        <p:txBody>
+          <a:bodyPr rtlCol="0" anchor="ctr"/>
+          <a:lstStyle/>
+          <a:p>
+            <a:pPr algn="ctr"/>
+          </a:p>
+        </p:txBody>
+      </p:sp>
+      <p:sp>
+        <p:nvSpPr>
+          <p:cNvPr id="18" name="TextBox 17"/>
           <p:cNvSpPr txBox="1"/>
           <p:nvPr/>
         </p:nvSpPr>
         <p:spPr>
           <a:xfrm>
-            <a:off x="3657600" y="2423160"/>
-            <a:ext cx="2194560" cy="3566160"/>
+            <a:off x="6537960" y="2313432"/>
+            <a:ext cx="4572000" cy="713232"/>
           </a:xfrm>
           <a:prstGeom prst="rect">
             <a:avLst/>
@@ -6244,86 +6769,146 @@
           <a:lstStyle/>
           <a:p>
             <a:pPr>
-              <a:spcAft>
-                <a:spcPts val="600"/>
-              </a:spcAft>
-              <a:defRPr sz="950">
-                <a:solidFill>
-                  <a:srgbClr val="CADAEE"/>
-                </a:solidFill>
-                <a:latin typeface="Calibri"/>
-              </a:defRPr>
-            </a:pPr>
-            <a:r>
-              <a:t>• Continuous monitoring of remote or inaccessible wetlands.</a:t>
-            </a:r>
-          </a:p>
-          <a:p>
-            <a:pPr>
-              <a:spcAft>
-                <a:spcPts val="600"/>
-              </a:spcAft>
-              <a:defRPr sz="950">
-                <a:solidFill>
-                  <a:srgbClr val="CADAEE"/>
-                </a:solidFill>
-                <a:latin typeface="Calibri"/>
-              </a:defRPr>
-            </a:pPr>
-            <a:r>
-              <a:t>• Evidence-based data for conservation advocacy campaigns.</a:t>
-            </a:r>
-          </a:p>
-          <a:p>
-            <a:pPr>
-              <a:spcAft>
-                <a:spcPts val="600"/>
-              </a:spcAft>
-              <a:defRPr sz="950">
-                <a:solidFill>
-                  <a:srgbClr val="CADAEE"/>
-                </a:solidFill>
-                <a:latin typeface="Calibri"/>
-              </a:defRPr>
-            </a:pPr>
-            <a:r>
-              <a:t>• Field photo ground-truthing portal for community rangers.</a:t>
-            </a:r>
-          </a:p>
-          <a:p>
-            <a:pPr>
-              <a:spcAft>
-                <a:spcPts val="600"/>
-              </a:spcAft>
-              <a:defRPr sz="950">
-                <a:solidFill>
-                  <a:srgbClr val="CADAEE"/>
-                </a:solidFill>
-                <a:latin typeface="Calibri"/>
-              </a:defRPr>
-            </a:pPr>
-            <a:r>
-              <a:t>• Multi-year trend documentation to secure climate grants.</a:t>
-            </a:r>
-          </a:p>
-        </p:txBody>
-      </p:sp>
-      <p:sp>
-        <p:nvSpPr>
-          <p:cNvPr id="11" name="Rectangle 10"/>
+              <a:defRPr sz="850" b="1">
+                <a:solidFill>
+                  <a:srgbClr val="06D6A0"/>
+                </a:solidFill>
+                <a:latin typeface="Consolas"/>
+              </a:defRPr>
+            </a:pPr>
+            <a:r>
+              <a:t>PHASE 1: CURRENT PRODUCTION  //  BENCHMARK DEPLOYMENT</a:t>
+            </a:r>
+          </a:p>
+          <a:p>
+            <a:pPr>
+              <a:spcBef>
+                <a:spcPts val="200"/>
+              </a:spcBef>
+              <a:defRPr sz="800">
+                <a:solidFill>
+                  <a:srgbClr val="CADAEE"/>
+                </a:solidFill>
+              </a:defRPr>
+            </a:pPr>
+            <a:r>
+              <a:t>✔ STAC pipeline, sub-second NDWI canvas kernel, Gemini 4-mode AI, JSON audit provenance, and Pallikaranai audit.</a:t>
+            </a:r>
+          </a:p>
+        </p:txBody>
+      </p:sp>
+      <p:sp>
+        <p:nvSpPr>
+          <p:cNvPr id="19" name="Rectangle 18"/>
           <p:cNvSpPr/>
           <p:nvPr/>
         </p:nvSpPr>
         <p:spPr>
           <a:xfrm>
-            <a:off x="6217920" y="1645920"/>
-            <a:ext cx="2560320" cy="4480560"/>
+            <a:off x="6400800" y="3172968"/>
+            <a:ext cx="4846320" cy="841248"/>
           </a:xfrm>
           <a:prstGeom prst="rect">
             <a:avLst/>
           </a:prstGeom>
           <a:solidFill>
-            <a:srgbClr val="0C1E3D"/>
+            <a:srgbClr val="071326"/>
+          </a:solidFill>
+          <a:ln w="12700">
+            <a:solidFill>
+              <a:srgbClr val="22D3EE"/>
+            </a:solidFill>
+          </a:ln>
+        </p:spPr>
+        <p:style>
+          <a:lnRef idx="1">
+            <a:schemeClr val="accent1"/>
+          </a:lnRef>
+          <a:fillRef idx="3">
+            <a:schemeClr val="accent1"/>
+          </a:fillRef>
+          <a:effectRef idx="2">
+            <a:schemeClr val="accent1"/>
+          </a:effectRef>
+          <a:fontRef idx="minor">
+            <a:schemeClr val="lt1"/>
+          </a:fontRef>
+        </p:style>
+        <p:txBody>
+          <a:bodyPr rtlCol="0" anchor="ctr"/>
+          <a:lstStyle/>
+          <a:p>
+            <a:pPr algn="ctr"/>
+          </a:p>
+        </p:txBody>
+      </p:sp>
+      <p:sp>
+        <p:nvSpPr>
+          <p:cNvPr id="20" name="TextBox 19"/>
+          <p:cNvSpPr txBox="1"/>
+          <p:nvPr/>
+        </p:nvSpPr>
+        <p:spPr>
+          <a:xfrm>
+            <a:off x="6537960" y="3246120"/>
+            <a:ext cx="4572000" cy="713232"/>
+          </a:xfrm>
+          <a:prstGeom prst="rect">
+            <a:avLst/>
+          </a:prstGeom>
+          <a:noFill/>
+        </p:spPr>
+        <p:txBody>
+          <a:bodyPr wrap="square" lIns="0" tIns="0" rIns="0" bIns="0">
+            <a:spAutoFit/>
+          </a:bodyPr>
+          <a:lstStyle/>
+          <a:p>
+            <a:pPr>
+              <a:defRPr sz="850" b="1">
+                <a:solidFill>
+                  <a:srgbClr val="22D3EE"/>
+                </a:solidFill>
+                <a:latin typeface="Consolas"/>
+              </a:defRPr>
+            </a:pPr>
+            <a:r>
+              <a:t>PHASE 2: Q4 2025  //  MULTI-SENSOR RADAR FUSION</a:t>
+            </a:r>
+          </a:p>
+          <a:p>
+            <a:pPr>
+              <a:spcBef>
+                <a:spcPts val="200"/>
+              </a:spcBef>
+              <a:defRPr sz="800">
+                <a:solidFill>
+                  <a:srgbClr val="CADAEE"/>
+                </a:solidFill>
+              </a:defRPr>
+            </a:pPr>
+            <a:r>
+              <a:t>• Sentinel-1 SAR C-band radar (all-weather penetrating), MNDWI/AWEI indices, STAC webhook alerts, GeoJSON vector export.</a:t>
+            </a:r>
+          </a:p>
+        </p:txBody>
+      </p:sp>
+      <p:sp>
+        <p:nvSpPr>
+          <p:cNvPr id="21" name="Rectangle 20"/>
+          <p:cNvSpPr/>
+          <p:nvPr/>
+        </p:nvSpPr>
+        <p:spPr>
+          <a:xfrm>
+            <a:off x="6400800" y="4105656"/>
+            <a:ext cx="4846320" cy="841248"/>
+          </a:xfrm>
+          <a:prstGeom prst="rect">
+            <a:avLst/>
+          </a:prstGeom>
+          <a:solidFill>
+            <a:srgbClr val="071326"/>
           </a:solidFill>
           <a:ln w="12700">
             <a:solidFill>
@@ -6355,14 +6940,14 @@
       </p:sp>
       <p:sp>
         <p:nvSpPr>
-          <p:cNvPr id="12" name="TextBox 11"/>
+          <p:cNvPr id="22" name="TextBox 21"/>
           <p:cNvSpPr txBox="1"/>
           <p:nvPr/>
         </p:nvSpPr>
         <p:spPr>
           <a:xfrm>
-            <a:off x="6400800" y="1792224"/>
-            <a:ext cx="2194560" cy="594360"/>
+            <a:off x="6537960" y="4178808"/>
+            <a:ext cx="4572000" cy="713232"/>
           </a:xfrm>
           <a:prstGeom prst="rect">
             <a:avLst/>
@@ -6376,138 +6961,50 @@
           <a:lstStyle/>
           <a:p>
             <a:pPr>
-              <a:spcAft>
+              <a:defRPr sz="850" b="1">
+                <a:solidFill>
+                  <a:srgbClr val="FBBF24"/>
+                </a:solidFill>
+                <a:latin typeface="Consolas"/>
+              </a:defRPr>
+            </a:pPr>
+            <a:r>
+              <a:t>PHASE 3: Q1 2026  //  ACTIVE LEARNING ML</a:t>
+            </a:r>
+          </a:p>
+          <a:p>
+            <a:pPr>
+              <a:spcBef>
                 <a:spcPts val="200"/>
-              </a:spcAft>
-              <a:defRPr sz="800" b="1">
-                <a:solidFill>
-                  <a:srgbClr val="22D3EE"/>
-                </a:solidFill>
-                <a:latin typeface="Consolas"/>
-              </a:defRPr>
-            </a:pPr>
-            <a:r>
-              <a:t>DISASTER MITIGATION</a:t>
-            </a:r>
-          </a:p>
-          <a:p>
-            <a:pPr>
-              <a:defRPr sz="1300" b="1">
-                <a:solidFill>
-                  <a:srgbClr val="F0FDFA"/>
-                </a:solidFill>
-                <a:latin typeface="Trebuchet MS"/>
-              </a:defRPr>
-            </a:pPr>
-            <a:r>
-              <a:t>🏙️ SMART CITIES &amp; PLANNERS</a:t>
-            </a:r>
-          </a:p>
-        </p:txBody>
-      </p:sp>
-      <p:sp>
-        <p:nvSpPr>
-          <p:cNvPr id="13" name="TextBox 12"/>
-          <p:cNvSpPr txBox="1"/>
-          <p:nvPr/>
-        </p:nvSpPr>
-        <p:spPr>
-          <a:xfrm>
-            <a:off x="6400800" y="2423160"/>
-            <a:ext cx="2194560" cy="3566160"/>
-          </a:xfrm>
-          <a:prstGeom prst="rect">
-            <a:avLst/>
-          </a:prstGeom>
-          <a:noFill/>
-        </p:spPr>
-        <p:txBody>
-          <a:bodyPr wrap="square" lIns="0" tIns="0" rIns="0" bIns="0">
-            <a:spAutoFit/>
-          </a:bodyPr>
-          <a:lstStyle/>
-          <a:p>
-            <a:pPr>
-              <a:spcAft>
-                <a:spcPts val="600"/>
-              </a:spcAft>
-              <a:defRPr sz="950">
-                <a:solidFill>
-                  <a:srgbClr val="CADAEE"/>
-                </a:solidFill>
-                <a:latin typeface="Calibri"/>
-              </a:defRPr>
-            </a:pPr>
-            <a:r>
-              <a:t>• Pre-monsoon water holding capacity assessments.</a:t>
-            </a:r>
-          </a:p>
-          <a:p>
-            <a:pPr>
-              <a:spcAft>
-                <a:spcPts val="600"/>
-              </a:spcAft>
-              <a:defRPr sz="950">
-                <a:solidFill>
-                  <a:srgbClr val="CADAEE"/>
-                </a:solidFill>
-                <a:latin typeface="Calibri"/>
-              </a:defRPr>
-            </a:pPr>
-            <a:r>
-              <a:t>• Preservation of critical urban flood buffer corridors.</a:t>
-            </a:r>
-          </a:p>
-          <a:p>
-            <a:pPr>
-              <a:spcAft>
-                <a:spcPts val="600"/>
-              </a:spcAft>
-              <a:defRPr sz="950">
-                <a:solidFill>
-                  <a:srgbClr val="CADAEE"/>
-                </a:solidFill>
-                <a:latin typeface="Calibri"/>
-              </a:defRPr>
-            </a:pPr>
-            <a:r>
-              <a:t>• Resilience planning for expanding metropolitan zones.</a:t>
-            </a:r>
-          </a:p>
-          <a:p>
-            <a:pPr>
-              <a:spcAft>
-                <a:spcPts val="600"/>
-              </a:spcAft>
-              <a:defRPr sz="950">
-                <a:solidFill>
-                  <a:srgbClr val="CADAEE"/>
-                </a:solidFill>
-                <a:latin typeface="Calibri"/>
-              </a:defRPr>
-            </a:pPr>
-            <a:r>
-              <a:t>• Integration with city emergency response dashboards.</a:t>
-            </a:r>
-          </a:p>
-        </p:txBody>
-      </p:sp>
-      <p:sp>
-        <p:nvSpPr>
-          <p:cNvPr id="14" name="Rectangle 13"/>
+              </a:spcBef>
+              <a:defRPr sz="800">
+                <a:solidFill>
+                  <a:srgbClr val="CADAEE"/>
+                </a:solidFill>
+              </a:defRPr>
+            </a:pPr>
+            <a:r>
+              <a:t>• Few-shot patch labeling UI, Prithvi-100M fine-tuning adapter, citizen science mobile photo portal, thermal water tracking.</a:t>
+            </a:r>
+          </a:p>
+        </p:txBody>
+      </p:sp>
+      <p:sp>
+        <p:nvSpPr>
+          <p:cNvPr id="23" name="Rectangle 22"/>
           <p:cNvSpPr/>
           <p:nvPr/>
         </p:nvSpPr>
         <p:spPr>
           <a:xfrm>
-            <a:off x="8961120" y="1645920"/>
-            <a:ext cx="2560320" cy="4480560"/>
+            <a:off x="6400800" y="5038344"/>
+            <a:ext cx="4846320" cy="841248"/>
           </a:xfrm>
           <a:prstGeom prst="rect">
             <a:avLst/>
           </a:prstGeom>
           <a:solidFill>
-            <a:srgbClr val="0C1E3D"/>
+            <a:srgbClr val="071326"/>
           </a:solidFill>
           <a:ln w="12700">
             <a:solidFill>
@@ -6539,14 +7036,14 @@
       </p:sp>
       <p:sp>
         <p:nvSpPr>
-          <p:cNvPr id="15" name="TextBox 14"/>
+          <p:cNvPr id="24" name="TextBox 23"/>
           <p:cNvSpPr txBox="1"/>
           <p:nvPr/>
         </p:nvSpPr>
         <p:spPr>
           <a:xfrm>
-            <a:off x="9144000" y="1792224"/>
-            <a:ext cx="2194560" cy="594360"/>
+            <a:off x="6537960" y="5111496"/>
+            <a:ext cx="4572000" cy="713232"/>
           </a:xfrm>
           <a:prstGeom prst="rect">
             <a:avLst/>
@@ -6560,314 +7057,15 @@
           <a:lstStyle/>
           <a:p>
             <a:pPr>
-              <a:spcAft>
-                <a:spcPts val="200"/>
-              </a:spcAft>
-              <a:defRPr sz="800" b="1">
-                <a:solidFill>
-                  <a:srgbClr val="22D3EE"/>
+              <a:defRPr sz="850" b="1">
+                <a:solidFill>
+                  <a:srgbClr val="F43F5E"/>
                 </a:solidFill>
                 <a:latin typeface="Consolas"/>
               </a:defRPr>
             </a:pPr>
             <a:r>
-              <a:t>SUSTAINABILITY AUDITING</a:t>
-            </a:r>
-          </a:p>
-          <a:p>
-            <a:pPr>
-              <a:defRPr sz="1300" b="1">
-                <a:solidFill>
-                  <a:srgbClr val="F0FDFA"/>
-                </a:solidFill>
-                <a:latin typeface="Trebuchet MS"/>
-              </a:defRPr>
-            </a:pPr>
-            <a:r>
-              <a:t>💼 ESG &amp; BLUE CARBON</a:t>
-            </a:r>
-          </a:p>
-        </p:txBody>
-      </p:sp>
-      <p:sp>
-        <p:nvSpPr>
-          <p:cNvPr id="16" name="TextBox 15"/>
-          <p:cNvSpPr txBox="1"/>
-          <p:nvPr/>
-        </p:nvSpPr>
-        <p:spPr>
-          <a:xfrm>
-            <a:off x="9144000" y="2423160"/>
-            <a:ext cx="2194560" cy="3566160"/>
-          </a:xfrm>
-          <a:prstGeom prst="rect">
-            <a:avLst/>
-          </a:prstGeom>
-          <a:noFill/>
-        </p:spPr>
-        <p:txBody>
-          <a:bodyPr wrap="square" lIns="0" tIns="0" rIns="0" bIns="0">
-            <a:spAutoFit/>
-          </a:bodyPr>
-          <a:lstStyle/>
-          <a:p>
-            <a:pPr>
-              <a:spcAft>
-                <a:spcPts val="600"/>
-              </a:spcAft>
-              <a:defRPr sz="950">
-                <a:solidFill>
-                  <a:srgbClr val="CADAEE"/>
-                </a:solidFill>
-                <a:latin typeface="Calibri"/>
-              </a:defRPr>
-            </a:pPr>
-            <a:r>
-              <a:t>• Independent satellite MRV (Measurement, Reporting &amp; Verification).</a:t>
-            </a:r>
-          </a:p>
-          <a:p>
-            <a:pPr>
-              <a:spcAft>
-                <a:spcPts val="600"/>
-              </a:spcAft>
-              <a:defRPr sz="950">
-                <a:solidFill>
-                  <a:srgbClr val="CADAEE"/>
-                </a:solidFill>
-                <a:latin typeface="Calibri"/>
-              </a:defRPr>
-            </a:pPr>
-            <a:r>
-              <a:t>• Auditable wetland carbon credit verification.</a:t>
-            </a:r>
-          </a:p>
-          <a:p>
-            <a:pPr>
-              <a:spcAft>
-                <a:spcPts val="600"/>
-              </a:spcAft>
-              <a:defRPr sz="950">
-                <a:solidFill>
-                  <a:srgbClr val="CADAEE"/>
-                </a:solidFill>
-                <a:latin typeface="Calibri"/>
-              </a:defRPr>
-            </a:pPr>
-            <a:r>
-              <a:t>• Corporate water stewardship compliance reporting.</a:t>
-            </a:r>
-          </a:p>
-          <a:p>
-            <a:pPr>
-              <a:spcAft>
-                <a:spcPts val="600"/>
-              </a:spcAft>
-              <a:defRPr sz="950">
-                <a:solidFill>
-                  <a:srgbClr val="CADAEE"/>
-                </a:solidFill>
-                <a:latin typeface="Calibri"/>
-              </a:defRPr>
-            </a:pPr>
-            <a:r>
-              <a:t>• Cryptographic system hashes preventing greenwashing.</a:t>
-            </a:r>
-          </a:p>
-        </p:txBody>
-      </p:sp>
-      <p:sp>
-        <p:nvSpPr>
-          <p:cNvPr id="17" name="TextBox 16"/>
-          <p:cNvSpPr txBox="1"/>
-          <p:nvPr/>
-        </p:nvSpPr>
-        <p:spPr>
-          <a:xfrm>
-            <a:off x="731520" y="6473952"/>
-            <a:ext cx="10698480" cy="274320"/>
-          </a:xfrm>
-          <a:prstGeom prst="rect">
-            <a:avLst/>
-          </a:prstGeom>
-          <a:noFill/>
-        </p:spPr>
-        <p:txBody>
-          <a:bodyPr wrap="none" lIns="0" tIns="0" rIns="0" bIns="0">
-            <a:spAutoFit/>
-          </a:bodyPr>
-          <a:lstStyle/>
-          <a:p>
-            <a:pPr algn="ctr">
-              <a:defRPr sz="750">
-                <a:solidFill>
-                  <a:srgbClr val="738CAD"/>
-                </a:solidFill>
-                <a:latin typeface="Consolas"/>
-              </a:defRPr>
-            </a:pPr>
-            <a:r>
-              <a:t>AQUASENSE OBSERVATORY • SENTINEL-2 L2A STAC • NDWI (B03-B08)/(B03+B08) • 10m/px • GEMINI 3.7 FLASH • 0x8a92f02c</a:t>
-            </a:r>
-          </a:p>
-        </p:txBody>
-      </p:sp>
-    </p:spTree>
-  </p:cSld>
-  <p:clrMapOvr>
-    <a:masterClrMapping/>
-  </p:clrMapOvr>
-</p:sld>
-</file>
-
-<file path=ppt/slides/slide12.xml><?xml version="1.0" encoding="utf-8"?>
-<p:sld xmlns:a="http://schemas.openxmlformats.org/drawingml/2006/main" xmlns:p="http://schemas.openxmlformats.org/presentationml/2006/main" xmlns:r="http://schemas.openxmlformats.org/officeDocument/2006/relationships">
-  <p:cSld>
-    <p:bg>
-      <p:bgPr>
-        <a:solidFill>
-          <a:srgbClr val="030712"/>
-        </a:solidFill>
-        <a:effectLst/>
-      </p:bgPr>
-    </p:bg>
-    <p:spTree>
-      <p:nvGrpSpPr>
-        <p:cNvPr id="1" name=""/>
-        <p:cNvGrpSpPr/>
-        <p:nvPr/>
-      </p:nvGrpSpPr>
-      <p:grpSpPr/>
-      <p:sp>
-        <p:nvSpPr>
-          <p:cNvPr id="2" name="Rectangle 1"/>
-          <p:cNvSpPr/>
-          <p:nvPr/>
-        </p:nvSpPr>
-        <p:spPr>
-          <a:xfrm>
-            <a:off x="731520" y="365760"/>
-            <a:ext cx="1645920" cy="38100"/>
-          </a:xfrm>
-          <a:prstGeom prst="rect">
-            <a:avLst/>
-          </a:prstGeom>
-          <a:solidFill>
-            <a:srgbClr val="22D3EE"/>
-          </a:solidFill>
-          <a:ln>
-            <a:noFill/>
-          </a:ln>
-        </p:spPr>
-        <p:style>
-          <a:lnRef idx="1">
-            <a:schemeClr val="accent1"/>
-          </a:lnRef>
-          <a:fillRef idx="3">
-            <a:schemeClr val="accent1"/>
-          </a:fillRef>
-          <a:effectRef idx="2">
-            <a:schemeClr val="accent1"/>
-          </a:effectRef>
-          <a:fontRef idx="minor">
-            <a:schemeClr val="lt1"/>
-          </a:fontRef>
-        </p:style>
-        <p:txBody>
-          <a:bodyPr rtlCol="0" anchor="ctr"/>
-          <a:lstStyle/>
-          <a:p>
-            <a:pPr algn="ctr"/>
-          </a:p>
-        </p:txBody>
-      </p:sp>
-      <p:sp>
-        <p:nvSpPr>
-          <p:cNvPr id="3" name="Rounded Rectangle 2"/>
-          <p:cNvSpPr/>
-          <p:nvPr/>
-        </p:nvSpPr>
-        <p:spPr>
-          <a:xfrm>
-            <a:off x="731520" y="475488"/>
-            <a:ext cx="1645920" cy="256032"/>
-          </a:xfrm>
-          <a:prstGeom prst="roundRect">
-            <a:avLst/>
-          </a:prstGeom>
-          <a:solidFill>
-            <a:srgbClr val="0C1E3D"/>
-          </a:solidFill>
-          <a:ln w="9525">
-            <a:solidFill>
-              <a:srgbClr val="1D3D73"/>
-            </a:solidFill>
-          </a:ln>
-        </p:spPr>
-        <p:style>
-          <a:lnRef idx="1">
-            <a:schemeClr val="accent1"/>
-          </a:lnRef>
-          <a:fillRef idx="3">
-            <a:schemeClr val="accent1"/>
-          </a:fillRef>
-          <a:effectRef idx="2">
-            <a:schemeClr val="accent1"/>
-          </a:effectRef>
-          <a:fontRef idx="minor">
-            <a:schemeClr val="lt1"/>
-          </a:fontRef>
-        </p:style>
-        <p:txBody>
-          <a:bodyPr rtlCol="0" anchor="ctr" wrap="none" lIns="54864" rIns="54864" tIns="18288" bIns="18288"/>
-          <a:lstStyle/>
-          <a:p>
-            <a:pPr algn="ctr">
-              <a:defRPr sz="850" b="1">
-                <a:solidFill>
-                  <a:srgbClr val="FBBF24"/>
-                </a:solidFill>
-                <a:latin typeface="Consolas"/>
-              </a:defRPr>
-            </a:pPr>
-            <a:r>
-              <a:t>ORBIT 12 // STRATEGIC ROADMAP</a:t>
-            </a:r>
-          </a:p>
-        </p:txBody>
-      </p:sp>
-      <p:sp>
-        <p:nvSpPr>
-          <p:cNvPr id="4" name="TextBox 3"/>
-          <p:cNvSpPr txBox="1"/>
-          <p:nvPr/>
-        </p:nvSpPr>
-        <p:spPr>
-          <a:xfrm>
-            <a:off x="731520" y="749808"/>
-            <a:ext cx="10698480" cy="594360"/>
-          </a:xfrm>
-          <a:prstGeom prst="rect">
-            <a:avLst/>
-          </a:prstGeom>
-          <a:noFill/>
-        </p:spPr>
-        <p:txBody>
-          <a:bodyPr wrap="square" lIns="0" tIns="0" rIns="0" bIns="0">
-            <a:spAutoFit/>
-          </a:bodyPr>
-          <a:lstStyle/>
-          <a:p>
-            <a:pPr>
-              <a:defRPr sz="2400" b="1">
-                <a:solidFill>
-                  <a:srgbClr val="F0FDFA"/>
-                </a:solidFill>
-                <a:latin typeface="Trebuchet MS"/>
-              </a:defRPr>
-            </a:pPr>
-            <a:r>
-              <a:t>Product Roadmap &amp; Planetary Scaling Vision</a:t>
+              <a:t>PHASE 4: 2027 VISION  //  PLANETARY HYDRO-NETWORK</a:t>
             </a:r>
           </a:p>
           <a:p>
@@ -6875,790 +7073,21 @@
               <a:spcBef>
                 <a:spcPts val="200"/>
               </a:spcBef>
-              <a:defRPr sz="1150">
-                <a:solidFill>
-                  <a:srgbClr val="738CAD"/>
-                </a:solidFill>
-                <a:latin typeface="Calibri"/>
-              </a:defRPr>
-            </a:pPr>
-            <a:r>
-              <a:t>From local wetland observatory to an autonomous global planetary hydro-intelligence network.</a:t>
-            </a:r>
-          </a:p>
-        </p:txBody>
-      </p:sp>
-      <p:sp>
-        <p:nvSpPr>
-          <p:cNvPr id="5" name="Rectangle 4"/>
-          <p:cNvSpPr/>
-          <p:nvPr/>
-        </p:nvSpPr>
-        <p:spPr>
-          <a:xfrm>
-            <a:off x="731520" y="1645920"/>
-            <a:ext cx="2560320" cy="4480560"/>
-          </a:xfrm>
-          <a:prstGeom prst="rect">
-            <a:avLst/>
-          </a:prstGeom>
-          <a:solidFill>
-            <a:srgbClr val="0C1E3D"/>
-          </a:solidFill>
-          <a:ln w="12700">
-            <a:solidFill>
-              <a:srgbClr val="06D6A0"/>
-            </a:solidFill>
-          </a:ln>
-        </p:spPr>
-        <p:style>
-          <a:lnRef idx="1">
-            <a:schemeClr val="accent1"/>
-          </a:lnRef>
-          <a:fillRef idx="3">
-            <a:schemeClr val="accent1"/>
-          </a:fillRef>
-          <a:effectRef idx="2">
-            <a:schemeClr val="accent1"/>
-          </a:effectRef>
-          <a:fontRef idx="minor">
-            <a:schemeClr val="lt1"/>
-          </a:fontRef>
-        </p:style>
-        <p:txBody>
-          <a:bodyPr rtlCol="0" anchor="ctr"/>
-          <a:lstStyle/>
-          <a:p>
-            <a:pPr algn="ctr"/>
-          </a:p>
-        </p:txBody>
-      </p:sp>
-      <p:sp>
-        <p:nvSpPr>
-          <p:cNvPr id="6" name="TextBox 5"/>
-          <p:cNvSpPr txBox="1"/>
-          <p:nvPr/>
-        </p:nvSpPr>
-        <p:spPr>
-          <a:xfrm>
-            <a:off x="914400" y="1792224"/>
-            <a:ext cx="2194560" cy="594360"/>
-          </a:xfrm>
-          <a:prstGeom prst="rect">
-            <a:avLst/>
-          </a:prstGeom>
-          <a:noFill/>
-        </p:spPr>
-        <p:txBody>
-          <a:bodyPr wrap="square" lIns="0" tIns="0" rIns="0" bIns="0">
-            <a:spAutoFit/>
-          </a:bodyPr>
-          <a:lstStyle/>
-          <a:p>
-            <a:pPr>
-              <a:spcAft>
-                <a:spcPts val="200"/>
-              </a:spcAft>
-              <a:defRPr sz="800" b="1">
-                <a:solidFill>
-                  <a:srgbClr val="22D3EE"/>
-                </a:solidFill>
-                <a:latin typeface="Consolas"/>
-              </a:defRPr>
-            </a:pPr>
-            <a:r>
-              <a:t>PHASE 1: PRODUCTION</a:t>
-            </a:r>
-          </a:p>
-          <a:p>
-            <a:pPr>
-              <a:defRPr sz="1300" b="1">
-                <a:solidFill>
-                  <a:srgbClr val="F0FDFA"/>
-                </a:solidFill>
-                <a:latin typeface="Trebuchet MS"/>
-              </a:defRPr>
-            </a:pPr>
-            <a:r>
-              <a:t>CURRENT BENCHMARK</a:t>
-            </a:r>
-          </a:p>
-        </p:txBody>
-      </p:sp>
-      <p:sp>
-        <p:nvSpPr>
-          <p:cNvPr id="7" name="TextBox 6"/>
-          <p:cNvSpPr txBox="1"/>
-          <p:nvPr/>
-        </p:nvSpPr>
-        <p:spPr>
-          <a:xfrm>
-            <a:off x="914400" y="2423160"/>
-            <a:ext cx="2194560" cy="3566160"/>
-          </a:xfrm>
-          <a:prstGeom prst="rect">
-            <a:avLst/>
-          </a:prstGeom>
-          <a:noFill/>
-        </p:spPr>
-        <p:txBody>
-          <a:bodyPr wrap="square" lIns="0" tIns="0" rIns="0" bIns="0">
-            <a:spAutoFit/>
-          </a:bodyPr>
-          <a:lstStyle/>
-          <a:p>
-            <a:pPr>
-              <a:spcAft>
-                <a:spcPts val="600"/>
-              </a:spcAft>
-              <a:defRPr sz="950">
-                <a:solidFill>
-                  <a:srgbClr val="CADAEE"/>
-                </a:solidFill>
-                <a:latin typeface="Calibri"/>
-              </a:defRPr>
-            </a:pPr>
-            <a:r>
-              <a:t>✔ STAC Planetary Computer pipeline</a:t>
-            </a:r>
-          </a:p>
-          <a:p>
-            <a:pPr>
-              <a:spcAft>
-                <a:spcPts val="600"/>
-              </a:spcAft>
-              <a:defRPr sz="950">
-                <a:solidFill>
-                  <a:srgbClr val="CADAEE"/>
-                </a:solidFill>
-                <a:latin typeface="Calibri"/>
-              </a:defRPr>
-            </a:pPr>
-            <a:r>
-              <a:t>✔ Sub-second NDWI canvas kernel</a:t>
-            </a:r>
-          </a:p>
-          <a:p>
-            <a:pPr>
-              <a:spcAft>
-                <a:spcPts val="600"/>
-              </a:spcAft>
-              <a:defRPr sz="950">
-                <a:solidFill>
-                  <a:srgbClr val="CADAEE"/>
-                </a:solidFill>
-                <a:latin typeface="Calibri"/>
-              </a:defRPr>
-            </a:pPr>
-            <a:r>
-              <a:t>✔ 7 Scientific Color LUT palettes</a:t>
-            </a:r>
-          </a:p>
-          <a:p>
-            <a:pPr>
-              <a:spcAft>
-                <a:spcPts val="600"/>
-              </a:spcAft>
-              <a:defRPr sz="950">
-                <a:solidFill>
-                  <a:srgbClr val="CADAEE"/>
-                </a:solidFill>
-                <a:latin typeface="Calibri"/>
-              </a:defRPr>
-            </a:pPr>
-            <a:r>
-              <a:t>✔ Gemini 4-mode AI synthesis suite</a:t>
-            </a:r>
-          </a:p>
-          <a:p>
-            <a:pPr>
-              <a:spcAft>
-                <a:spcPts val="600"/>
-              </a:spcAft>
-              <a:defRPr sz="950">
-                <a:solidFill>
-                  <a:srgbClr val="CADAEE"/>
-                </a:solidFill>
-                <a:latin typeface="Calibri"/>
-              </a:defRPr>
-            </a:pPr>
-            <a:r>
-              <a:t>✔ JSON audit provenance exporter</a:t>
-            </a:r>
-          </a:p>
-          <a:p>
-            <a:pPr>
-              <a:spcAft>
-                <a:spcPts val="600"/>
-              </a:spcAft>
-              <a:defRPr sz="950">
-                <a:solidFill>
-                  <a:srgbClr val="CADAEE"/>
-                </a:solidFill>
-                <a:latin typeface="Calibri"/>
-              </a:defRPr>
-            </a:pPr>
-            <a:r>
-              <a:t>✔ Pallikaranai Marshland validation</a:t>
-            </a:r>
-          </a:p>
-        </p:txBody>
-      </p:sp>
-      <p:sp>
-        <p:nvSpPr>
-          <p:cNvPr id="8" name="Rectangle 7"/>
-          <p:cNvSpPr/>
-          <p:nvPr/>
-        </p:nvSpPr>
-        <p:spPr>
-          <a:xfrm>
-            <a:off x="3474720" y="1645920"/>
-            <a:ext cx="2560320" cy="4480560"/>
-          </a:xfrm>
-          <a:prstGeom prst="rect">
-            <a:avLst/>
-          </a:prstGeom>
-          <a:solidFill>
-            <a:srgbClr val="0C1E3D"/>
-          </a:solidFill>
-          <a:ln w="12700">
-            <a:solidFill>
-              <a:srgbClr val="22D3EE"/>
-            </a:solidFill>
-          </a:ln>
-        </p:spPr>
-        <p:style>
-          <a:lnRef idx="1">
-            <a:schemeClr val="accent1"/>
-          </a:lnRef>
-          <a:fillRef idx="3">
-            <a:schemeClr val="accent1"/>
-          </a:fillRef>
-          <a:effectRef idx="2">
-            <a:schemeClr val="accent1"/>
-          </a:effectRef>
-          <a:fontRef idx="minor">
-            <a:schemeClr val="lt1"/>
-          </a:fontRef>
-        </p:style>
-        <p:txBody>
-          <a:bodyPr rtlCol="0" anchor="ctr"/>
-          <a:lstStyle/>
-          <a:p>
-            <a:pPr algn="ctr"/>
-          </a:p>
-        </p:txBody>
-      </p:sp>
-      <p:sp>
-        <p:nvSpPr>
-          <p:cNvPr id="9" name="TextBox 8"/>
-          <p:cNvSpPr txBox="1"/>
-          <p:nvPr/>
-        </p:nvSpPr>
-        <p:spPr>
-          <a:xfrm>
-            <a:off x="3657600" y="1792224"/>
-            <a:ext cx="2194560" cy="594360"/>
-          </a:xfrm>
-          <a:prstGeom prst="rect">
-            <a:avLst/>
-          </a:prstGeom>
-          <a:noFill/>
-        </p:spPr>
-        <p:txBody>
-          <a:bodyPr wrap="square" lIns="0" tIns="0" rIns="0" bIns="0">
-            <a:spAutoFit/>
-          </a:bodyPr>
-          <a:lstStyle/>
-          <a:p>
-            <a:pPr>
-              <a:spcAft>
-                <a:spcPts val="200"/>
-              </a:spcAft>
-              <a:defRPr sz="800" b="1">
-                <a:solidFill>
-                  <a:srgbClr val="22D3EE"/>
-                </a:solidFill>
-                <a:latin typeface="Consolas"/>
-              </a:defRPr>
-            </a:pPr>
-            <a:r>
-              <a:t>PHASE 2: Q4 2025</a:t>
-            </a:r>
-          </a:p>
-          <a:p>
-            <a:pPr>
-              <a:defRPr sz="1300" b="1">
-                <a:solidFill>
-                  <a:srgbClr val="F0FDFA"/>
-                </a:solidFill>
-                <a:latin typeface="Trebuchet MS"/>
-              </a:defRPr>
-            </a:pPr>
-            <a:r>
-              <a:t>MULTI-SENSOR FUSION</a:t>
-            </a:r>
-          </a:p>
-        </p:txBody>
-      </p:sp>
-      <p:sp>
-        <p:nvSpPr>
-          <p:cNvPr id="10" name="TextBox 9"/>
-          <p:cNvSpPr txBox="1"/>
-          <p:nvPr/>
-        </p:nvSpPr>
-        <p:spPr>
-          <a:xfrm>
-            <a:off x="3657600" y="2423160"/>
-            <a:ext cx="2194560" cy="3566160"/>
-          </a:xfrm>
-          <a:prstGeom prst="rect">
-            <a:avLst/>
-          </a:prstGeom>
-          <a:noFill/>
-        </p:spPr>
-        <p:txBody>
-          <a:bodyPr wrap="square" lIns="0" tIns="0" rIns="0" bIns="0">
-            <a:spAutoFit/>
-          </a:bodyPr>
-          <a:lstStyle/>
-          <a:p>
-            <a:pPr>
-              <a:spcAft>
-                <a:spcPts val="600"/>
-              </a:spcAft>
-              <a:defRPr sz="950">
-                <a:solidFill>
-                  <a:srgbClr val="CADAEE"/>
-                </a:solidFill>
-                <a:latin typeface="Calibri"/>
-              </a:defRPr>
-            </a:pPr>
-            <a:r>
-              <a:t>• Sentinel-1 SAR C-band radar integration (cloud-penetrating all-weather monitoring)</a:t>
-            </a:r>
-          </a:p>
-          <a:p>
-            <a:pPr>
-              <a:spcAft>
-                <a:spcPts val="600"/>
-              </a:spcAft>
-              <a:defRPr sz="950">
-                <a:solidFill>
-                  <a:srgbClr val="CADAEE"/>
-                </a:solidFill>
-                <a:latin typeface="Calibri"/>
-              </a:defRPr>
-            </a:pPr>
-            <a:r>
-              <a:t>• Multi-index support: MNDWI, AWEI, NDVI</a:t>
-            </a:r>
-          </a:p>
-          <a:p>
-            <a:pPr>
-              <a:spcAft>
-                <a:spcPts val="600"/>
-              </a:spcAft>
-              <a:defRPr sz="950">
-                <a:solidFill>
-                  <a:srgbClr val="CADAEE"/>
-                </a:solidFill>
-                <a:latin typeface="Calibri"/>
-              </a:defRPr>
-            </a:pPr>
-            <a:r>
-              <a:t>• Automated STAC webhook alerts on &gt;10% loss</a:t>
-            </a:r>
-          </a:p>
-          <a:p>
-            <a:pPr>
-              <a:spcAft>
-                <a:spcPts val="600"/>
-              </a:spcAft>
-              <a:defRPr sz="950">
-                <a:solidFill>
-                  <a:srgbClr val="CADAEE"/>
-                </a:solidFill>
-                <a:latin typeface="Calibri"/>
-              </a:defRPr>
-            </a:pPr>
-            <a:r>
-              <a:t>• Vector GeoJSON &amp; SHP polygon download</a:t>
-            </a:r>
-          </a:p>
-        </p:txBody>
-      </p:sp>
-      <p:sp>
-        <p:nvSpPr>
-          <p:cNvPr id="11" name="Rectangle 10"/>
-          <p:cNvSpPr/>
-          <p:nvPr/>
-        </p:nvSpPr>
-        <p:spPr>
-          <a:xfrm>
-            <a:off x="6217920" y="1645920"/>
-            <a:ext cx="2560320" cy="4480560"/>
-          </a:xfrm>
-          <a:prstGeom prst="rect">
-            <a:avLst/>
-          </a:prstGeom>
-          <a:solidFill>
-            <a:srgbClr val="0C1E3D"/>
-          </a:solidFill>
-          <a:ln w="12700">
-            <a:solidFill>
-              <a:srgbClr val="FBBF24"/>
-            </a:solidFill>
-          </a:ln>
-        </p:spPr>
-        <p:style>
-          <a:lnRef idx="1">
-            <a:schemeClr val="accent1"/>
-          </a:lnRef>
-          <a:fillRef idx="3">
-            <a:schemeClr val="accent1"/>
-          </a:fillRef>
-          <a:effectRef idx="2">
-            <a:schemeClr val="accent1"/>
-          </a:effectRef>
-          <a:fontRef idx="minor">
-            <a:schemeClr val="lt1"/>
-          </a:fontRef>
-        </p:style>
-        <p:txBody>
-          <a:bodyPr rtlCol="0" anchor="ctr"/>
-          <a:lstStyle/>
-          <a:p>
-            <a:pPr algn="ctr"/>
-          </a:p>
-        </p:txBody>
-      </p:sp>
-      <p:sp>
-        <p:nvSpPr>
-          <p:cNvPr id="12" name="TextBox 11"/>
-          <p:cNvSpPr txBox="1"/>
-          <p:nvPr/>
-        </p:nvSpPr>
-        <p:spPr>
-          <a:xfrm>
-            <a:off x="6400800" y="1792224"/>
-            <a:ext cx="2194560" cy="594360"/>
-          </a:xfrm>
-          <a:prstGeom prst="rect">
-            <a:avLst/>
-          </a:prstGeom>
-          <a:noFill/>
-        </p:spPr>
-        <p:txBody>
-          <a:bodyPr wrap="square" lIns="0" tIns="0" rIns="0" bIns="0">
-            <a:spAutoFit/>
-          </a:bodyPr>
-          <a:lstStyle/>
-          <a:p>
-            <a:pPr>
-              <a:spcAft>
-                <a:spcPts val="200"/>
-              </a:spcAft>
-              <a:defRPr sz="800" b="1">
-                <a:solidFill>
-                  <a:srgbClr val="22D3EE"/>
-                </a:solidFill>
-                <a:latin typeface="Consolas"/>
-              </a:defRPr>
-            </a:pPr>
-            <a:r>
-              <a:t>PHASE 3: Q1 2026</a:t>
-            </a:r>
-          </a:p>
-          <a:p>
-            <a:pPr>
-              <a:defRPr sz="1300" b="1">
-                <a:solidFill>
-                  <a:srgbClr val="F0FDFA"/>
-                </a:solidFill>
-                <a:latin typeface="Trebuchet MS"/>
-              </a:defRPr>
-            </a:pPr>
-            <a:r>
-              <a:t>ACTIVE LEARNING ML</a:t>
-            </a:r>
-          </a:p>
-        </p:txBody>
-      </p:sp>
-      <p:sp>
-        <p:nvSpPr>
-          <p:cNvPr id="13" name="TextBox 12"/>
-          <p:cNvSpPr txBox="1"/>
-          <p:nvPr/>
-        </p:nvSpPr>
-        <p:spPr>
-          <a:xfrm>
-            <a:off x="6400800" y="2423160"/>
-            <a:ext cx="2194560" cy="3566160"/>
-          </a:xfrm>
-          <a:prstGeom prst="rect">
-            <a:avLst/>
-          </a:prstGeom>
-          <a:noFill/>
-        </p:spPr>
-        <p:txBody>
-          <a:bodyPr wrap="square" lIns="0" tIns="0" rIns="0" bIns="0">
-            <a:spAutoFit/>
-          </a:bodyPr>
-          <a:lstStyle/>
-          <a:p>
-            <a:pPr>
-              <a:spcAft>
-                <a:spcPts val="600"/>
-              </a:spcAft>
-              <a:defRPr sz="950">
-                <a:solidFill>
-                  <a:srgbClr val="CADAEE"/>
-                </a:solidFill>
-                <a:latin typeface="Calibri"/>
-              </a:defRPr>
-            </a:pPr>
-            <a:r>
-              <a:t>• Interactive few-shot patch labeling UI</a:t>
-            </a:r>
-          </a:p>
-          <a:p>
-            <a:pPr>
-              <a:spcAft>
-                <a:spcPts val="600"/>
-              </a:spcAft>
-              <a:defRPr sz="950">
-                <a:solidFill>
-                  <a:srgbClr val="CADAEE"/>
-                </a:solidFill>
-                <a:latin typeface="Calibri"/>
-              </a:defRPr>
-            </a:pPr>
-            <a:r>
-              <a:t>• Prithvi-100M active fine-tuning adapter</a:t>
-            </a:r>
-          </a:p>
-          <a:p>
-            <a:pPr>
-              <a:spcAft>
-                <a:spcPts val="600"/>
-              </a:spcAft>
-              <a:defRPr sz="950">
-                <a:solidFill>
-                  <a:srgbClr val="CADAEE"/>
-                </a:solidFill>
-                <a:latin typeface="Calibri"/>
-              </a:defRPr>
-            </a:pPr>
-            <a:r>
-              <a:t>• Citizen science mobile photo portal</a:t>
-            </a:r>
-          </a:p>
-          <a:p>
-            <a:pPr>
-              <a:spcAft>
-                <a:spcPts val="600"/>
-              </a:spcAft>
-              <a:defRPr sz="950">
-                <a:solidFill>
-                  <a:srgbClr val="CADAEE"/>
-                </a:solidFill>
-                <a:latin typeface="Calibri"/>
-              </a:defRPr>
-            </a:pPr>
-            <a:r>
-              <a:t>• Landsat-8/9 thermal water anomaly tracking</a:t>
-            </a:r>
-          </a:p>
-        </p:txBody>
-      </p:sp>
-      <p:sp>
-        <p:nvSpPr>
-          <p:cNvPr id="14" name="Rectangle 13"/>
-          <p:cNvSpPr/>
-          <p:nvPr/>
-        </p:nvSpPr>
-        <p:spPr>
-          <a:xfrm>
-            <a:off x="8961120" y="1645920"/>
-            <a:ext cx="2560320" cy="4480560"/>
-          </a:xfrm>
-          <a:prstGeom prst="rect">
-            <a:avLst/>
-          </a:prstGeom>
-          <a:solidFill>
-            <a:srgbClr val="0C1E3D"/>
-          </a:solidFill>
-          <a:ln w="12700">
-            <a:solidFill>
-              <a:srgbClr val="F43F5E"/>
-            </a:solidFill>
-          </a:ln>
-        </p:spPr>
-        <p:style>
-          <a:lnRef idx="1">
-            <a:schemeClr val="accent1"/>
-          </a:lnRef>
-          <a:fillRef idx="3">
-            <a:schemeClr val="accent1"/>
-          </a:fillRef>
-          <a:effectRef idx="2">
-            <a:schemeClr val="accent1"/>
-          </a:effectRef>
-          <a:fontRef idx="minor">
-            <a:schemeClr val="lt1"/>
-          </a:fontRef>
-        </p:style>
-        <p:txBody>
-          <a:bodyPr rtlCol="0" anchor="ctr"/>
-          <a:lstStyle/>
-          <a:p>
-            <a:pPr algn="ctr"/>
-          </a:p>
-        </p:txBody>
-      </p:sp>
-      <p:sp>
-        <p:nvSpPr>
-          <p:cNvPr id="15" name="TextBox 14"/>
-          <p:cNvSpPr txBox="1"/>
-          <p:nvPr/>
-        </p:nvSpPr>
-        <p:spPr>
-          <a:xfrm>
-            <a:off x="9144000" y="1792224"/>
-            <a:ext cx="2194560" cy="594360"/>
-          </a:xfrm>
-          <a:prstGeom prst="rect">
-            <a:avLst/>
-          </a:prstGeom>
-          <a:noFill/>
-        </p:spPr>
-        <p:txBody>
-          <a:bodyPr wrap="square" lIns="0" tIns="0" rIns="0" bIns="0">
-            <a:spAutoFit/>
-          </a:bodyPr>
-          <a:lstStyle/>
-          <a:p>
-            <a:pPr>
-              <a:spcAft>
-                <a:spcPts val="200"/>
-              </a:spcAft>
-              <a:defRPr sz="800" b="1">
-                <a:solidFill>
-                  <a:srgbClr val="22D3EE"/>
-                </a:solidFill>
-                <a:latin typeface="Consolas"/>
-              </a:defRPr>
-            </a:pPr>
-            <a:r>
-              <a:t>PHASE 4: 2027 VISION</a:t>
-            </a:r>
-          </a:p>
-          <a:p>
-            <a:pPr>
-              <a:defRPr sz="1300" b="1">
-                <a:solidFill>
-                  <a:srgbClr val="F0FDFA"/>
-                </a:solidFill>
-                <a:latin typeface="Trebuchet MS"/>
-              </a:defRPr>
-            </a:pPr>
-            <a:r>
-              <a:t>PLANETARY HYDRO-NETWORK</a:t>
-            </a:r>
-          </a:p>
-        </p:txBody>
-      </p:sp>
-      <p:sp>
-        <p:nvSpPr>
-          <p:cNvPr id="16" name="TextBox 15"/>
-          <p:cNvSpPr txBox="1"/>
-          <p:nvPr/>
-        </p:nvSpPr>
-        <p:spPr>
-          <a:xfrm>
-            <a:off x="9144000" y="2423160"/>
-            <a:ext cx="2194560" cy="3566160"/>
-          </a:xfrm>
-          <a:prstGeom prst="rect">
-            <a:avLst/>
-          </a:prstGeom>
-          <a:noFill/>
-        </p:spPr>
-        <p:txBody>
-          <a:bodyPr wrap="square" lIns="0" tIns="0" rIns="0" bIns="0">
-            <a:spAutoFit/>
-          </a:bodyPr>
-          <a:lstStyle/>
-          <a:p>
-            <a:pPr>
-              <a:spcAft>
-                <a:spcPts val="600"/>
-              </a:spcAft>
-              <a:defRPr sz="950">
-                <a:solidFill>
-                  <a:srgbClr val="CADAEE"/>
-                </a:solidFill>
-                <a:latin typeface="Calibri"/>
-              </a:defRPr>
-            </a:pPr>
-            <a:r>
-              <a:t>• Pan-India &amp; Global Wetland Atlas</a:t>
-            </a:r>
-          </a:p>
-          <a:p>
-            <a:pPr>
-              <a:spcAft>
-                <a:spcPts val="600"/>
-              </a:spcAft>
-              <a:defRPr sz="950">
-                <a:solidFill>
-                  <a:srgbClr val="CADAEE"/>
-                </a:solidFill>
-                <a:latin typeface="Calibri"/>
-              </a:defRPr>
-            </a:pPr>
-            <a:r>
-              <a:t>• Real-time flood surge forecasting</a:t>
-            </a:r>
-          </a:p>
-          <a:p>
-            <a:pPr>
-              <a:spcAft>
-                <a:spcPts val="600"/>
-              </a:spcAft>
-              <a:defRPr sz="950">
-                <a:solidFill>
-                  <a:srgbClr val="CADAEE"/>
-                </a:solidFill>
-                <a:latin typeface="Calibri"/>
-              </a:defRPr>
-            </a:pPr>
-            <a:r>
-              <a:t>• Open public API for NGOs &amp; agencies</a:t>
-            </a:r>
-          </a:p>
-          <a:p>
-            <a:pPr>
-              <a:spcAft>
-                <a:spcPts val="600"/>
-              </a:spcAft>
-              <a:defRPr sz="950">
-                <a:solidFill>
-                  <a:srgbClr val="CADAEE"/>
-                </a:solidFill>
-                <a:latin typeface="Calibri"/>
-              </a:defRPr>
-            </a:pPr>
-            <a:r>
-              <a:t>• Automated Blue Carbon credit registry</a:t>
-            </a:r>
-          </a:p>
-        </p:txBody>
-      </p:sp>
-      <p:sp>
-        <p:nvSpPr>
-          <p:cNvPr id="17" name="TextBox 16"/>
+              <a:defRPr sz="800">
+                <a:solidFill>
+                  <a:srgbClr val="CADAEE"/>
+                </a:solidFill>
+              </a:defRPr>
+            </a:pPr>
+            <a:r>
+              <a:t>• Pan-India &amp; Global Wetland Atlas, real-time flood surge forecasting, open public API for NGOs, automated Blue Carbon registry.</a:t>
+            </a:r>
+          </a:p>
+        </p:txBody>
+      </p:sp>
+      <p:sp>
+        <p:nvSpPr>
+          <p:cNvPr id="25" name="TextBox 24"/>
           <p:cNvSpPr txBox="1"/>
           <p:nvPr/>
         </p:nvSpPr>
@@ -7770,7 +7199,7 @@
         <p:spPr>
           <a:xfrm>
             <a:off x="731520" y="475488"/>
-            <a:ext cx="1645920" cy="256032"/>
+            <a:ext cx="2011680" cy="256032"/>
           </a:xfrm>
           <a:prstGeom prst="roundRect">
             <a:avLst/>
@@ -7952,7 +7381,7 @@
           </a:p>
           <a:p>
             <a:pPr>
-              <a:defRPr sz="1300" b="1">
+              <a:defRPr sz="1200" b="1">
                 <a:solidFill>
                   <a:srgbClr val="F0FDFA"/>
                 </a:solidFill>
@@ -8146,7 +7575,7 @@
           </a:p>
           <a:p>
             <a:pPr>
-              <a:defRPr sz="1300" b="1">
+              <a:defRPr sz="1200" b="1">
                 <a:solidFill>
                   <a:srgbClr val="F0FDFA"/>
                 </a:solidFill>
@@ -8314,7 +7743,7 @@
           </a:p>
           <a:p>
             <a:pPr>
-              <a:defRPr sz="1300" b="1">
+              <a:defRPr sz="1200" b="1">
                 <a:solidFill>
                   <a:srgbClr val="F0FDFA"/>
                 </a:solidFill>
@@ -8512,7 +7941,7 @@
         <p:spPr>
           <a:xfrm>
             <a:off x="731520" y="475488"/>
-            <a:ext cx="1645920" cy="256032"/>
+            <a:ext cx="2011680" cy="256032"/>
           </a:xfrm>
           <a:prstGeom prst="roundRect">
             <a:avLst/>
@@ -8694,7 +8123,7 @@
           </a:p>
           <a:p>
             <a:pPr>
-              <a:defRPr sz="1300" b="1">
+              <a:defRPr sz="1200" b="1">
                 <a:solidFill>
                   <a:srgbClr val="F0FDFA"/>
                 </a:solidFill>
@@ -9029,7 +8458,7 @@
           </a:p>
           <a:p>
             <a:pPr>
-              <a:defRPr sz="1300" b="1">
+              <a:defRPr sz="1200" b="1">
                 <a:solidFill>
                   <a:srgbClr val="F0FDFA"/>
                 </a:solidFill>
@@ -9162,7 +8591,7 @@
           </a:p>
           <a:p>
             <a:pPr>
-              <a:defRPr sz="1300" b="1">
+              <a:defRPr sz="1200" b="1">
                 <a:solidFill>
                   <a:srgbClr val="F0FDFA"/>
                 </a:solidFill>
@@ -9295,7 +8724,7 @@
           </a:p>
           <a:p>
             <a:pPr>
-              <a:defRPr sz="1300" b="1">
+              <a:defRPr sz="1200" b="1">
                 <a:solidFill>
                   <a:srgbClr val="F0FDFA"/>
                 </a:solidFill>
@@ -9458,7 +8887,7 @@
         <p:spPr>
           <a:xfrm>
             <a:off x="731520" y="475488"/>
-            <a:ext cx="1645920" cy="256032"/>
+            <a:ext cx="2011680" cy="256032"/>
           </a:xfrm>
           <a:prstGeom prst="roundRect">
             <a:avLst/>
@@ -9640,7 +9069,7 @@
           </a:p>
           <a:p>
             <a:pPr>
-              <a:defRPr sz="1300" b="1">
+              <a:defRPr sz="1200" b="1">
                 <a:solidFill>
                   <a:srgbClr val="F0FDFA"/>
                 </a:solidFill>
@@ -9856,7 +9285,7 @@
           </a:p>
           <a:p>
             <a:pPr>
-              <a:defRPr sz="1300" b="1">
+              <a:defRPr sz="1200" b="1">
                 <a:solidFill>
                   <a:srgbClr val="F0FDFA"/>
                 </a:solidFill>
@@ -10072,7 +9501,7 @@
           </a:p>
           <a:p>
             <a:pPr>
-              <a:defRPr sz="1300" b="1">
+              <a:defRPr sz="1200" b="1">
                 <a:solidFill>
                   <a:srgbClr val="F0FDFA"/>
                 </a:solidFill>
@@ -10288,7 +9717,7 @@
           </a:p>
           <a:p>
             <a:pPr>
-              <a:defRPr sz="1300" b="1">
+              <a:defRPr sz="1200" b="1">
                 <a:solidFill>
                   <a:srgbClr val="F0FDFA"/>
                 </a:solidFill>
@@ -10534,7 +9963,7 @@
         <p:spPr>
           <a:xfrm>
             <a:off x="731520" y="475488"/>
-            <a:ext cx="1645920" cy="256032"/>
+            <a:ext cx="2011680" cy="256032"/>
           </a:xfrm>
           <a:prstGeom prst="roundRect">
             <a:avLst/>
@@ -10868,7 +10297,7 @@
         <p:spPr>
           <a:xfrm>
             <a:off x="731520" y="475488"/>
-            <a:ext cx="1645920" cy="256032"/>
+            <a:ext cx="2011680" cy="256032"/>
           </a:xfrm>
           <a:prstGeom prst="roundRect">
             <a:avLst/>
@@ -11050,7 +10479,7 @@
           </a:p>
           <a:p>
             <a:pPr>
-              <a:defRPr sz="1300" b="1">
+              <a:defRPr sz="1200" b="1">
                 <a:solidFill>
                   <a:srgbClr val="F0FDFA"/>
                 </a:solidFill>
@@ -11982,7 +11411,7 @@
           </a:p>
           <a:p>
             <a:pPr>
-              <a:defRPr sz="1300" b="1">
+              <a:defRPr sz="1200" b="1">
                 <a:solidFill>
                   <a:srgbClr val="F0FDFA"/>
                 </a:solidFill>
@@ -12164,7 +11593,7 @@
         <p:spPr>
           <a:xfrm>
             <a:off x="731520" y="475488"/>
-            <a:ext cx="1645920" cy="256032"/>
+            <a:ext cx="2011680" cy="256032"/>
           </a:xfrm>
           <a:prstGeom prst="roundRect">
             <a:avLst/>
@@ -12346,7 +11775,7 @@
           </a:p>
           <a:p>
             <a:pPr>
-              <a:defRPr sz="1300" b="1">
+              <a:defRPr sz="1200" b="1">
                 <a:solidFill>
                   <a:srgbClr val="F0FDFA"/>
                 </a:solidFill>
@@ -12633,7 +12062,7 @@
           </a:p>
           <a:p>
             <a:pPr>
-              <a:defRPr sz="1300" b="1">
+              <a:defRPr sz="1200" b="1">
                 <a:solidFill>
                   <a:srgbClr val="F0FDFA"/>
                 </a:solidFill>
@@ -12907,7 +12336,7 @@
           </a:p>
           <a:p>
             <a:pPr>
-              <a:defRPr sz="1300" b="1">
+              <a:defRPr sz="1200" b="1">
                 <a:solidFill>
                   <a:srgbClr val="F0FDFA"/>
                 </a:solidFill>
@@ -13224,7 +12653,7 @@
         <p:spPr>
           <a:xfrm>
             <a:off x="731520" y="475488"/>
-            <a:ext cx="1645920" cy="256032"/>
+            <a:ext cx="2011680" cy="256032"/>
           </a:xfrm>
           <a:prstGeom prst="roundRect">
             <a:avLst/>
@@ -13406,7 +12835,7 @@
           </a:p>
           <a:p>
             <a:pPr>
-              <a:defRPr sz="1300" b="1">
+              <a:defRPr sz="1200" b="1">
                 <a:solidFill>
                   <a:srgbClr val="F0FDFA"/>
                 </a:solidFill>
@@ -13590,7 +13019,7 @@
           </a:p>
           <a:p>
             <a:pPr>
-              <a:defRPr sz="1300" b="1">
+              <a:defRPr sz="1200" b="1">
                 <a:solidFill>
                   <a:srgbClr val="F0FDFA"/>
                 </a:solidFill>
@@ -13774,7 +13203,7 @@
           </a:p>
           <a:p>
             <a:pPr>
-              <a:defRPr sz="1300" b="1">
+              <a:defRPr sz="1200" b="1">
                 <a:solidFill>
                   <a:srgbClr val="F0FDFA"/>
                 </a:solidFill>
@@ -14080,7 +13509,7 @@
           </a:p>
           <a:p>
             <a:pPr>
-              <a:defRPr sz="1300" b="1">
+              <a:defRPr sz="1200" b="1">
                 <a:solidFill>
                   <a:srgbClr val="F0FDFA"/>
                 </a:solidFill>
@@ -14278,7 +13707,7 @@
         <p:spPr>
           <a:xfrm>
             <a:off x="731520" y="475488"/>
-            <a:ext cx="1645920" cy="256032"/>
+            <a:ext cx="2011680" cy="256032"/>
           </a:xfrm>
           <a:prstGeom prst="roundRect">
             <a:avLst/>
@@ -14460,7 +13889,7 @@
           </a:p>
           <a:p>
             <a:pPr>
-              <a:defRPr sz="1300" b="1">
+              <a:defRPr sz="1200" b="1">
                 <a:solidFill>
                   <a:srgbClr val="F0FDFA"/>
                 </a:solidFill>
@@ -14782,7 +14211,7 @@
           </a:p>
           <a:p>
             <a:pPr>
-              <a:defRPr sz="1300" b="1">
+              <a:defRPr sz="1200" b="1">
                 <a:solidFill>
                   <a:srgbClr val="F0FDFA"/>
                 </a:solidFill>

</xml_diff>